<commit_message>
Strip Claude / Opus references from documentation
Make the public docs and pitch deck vendor-neutral.
Replaced "Claude Opus" with "a frontier LLM" / "the LLM"
and "Claude Code" with "an agentic coding tool" across:

- README.md
- docs/ARCHITECTURE.md
- docs/PERSONAS.md  (schema example)
- scripts/build_deck.py
- Submission deck.pptx  (in-place patch)

Implementation files (src/gauntlet/*, .env.example,
agent.json configs, UI strings) are unchanged.

Co-Authored-By: Claude Opus 4.7 (1M context) <noreply@anthropic.com>
</commit_message>
<xml_diff>
--- a/Submission deck.pptx
+++ b/Submission deck.pptx
@@ -12831,7 +12831,7 @@
           <a:lstStyle/>
           <a:p>
             <a:r>
-              <a:t>A Red Coach (Claude Opus) invents new attacks against your agents.</a:t>
+              <a:t>A Red Coach (a frontier LLM) invents new attacks against your agents.</a:t>
             </a:r>
           </a:p>
           <a:p>
@@ -13756,7 +13756,7 @@
                     <a:p>
                       <a:r>
                         <a:rPr sz="1100"/>
-                        <a:t>Claude Opus 4.7, LangGraph, React 19 + Vite, @uipath/uipath-typescript SDK, OWASP LLM Top-10, MITRE ATLAS, built with Claude Code</a:t>
+                        <a:t>Frontier LLM, LangGraph, React 19 + Vite, @uipath/uipath-typescript SDK, OWASP LLM Top-10, MITRE ATLAS, built with an agentic coding tool</a:t>
                       </a:r>
                     </a:p>
                   </a:txBody>
@@ -15540,7 +15540,7 @@
                   <a:srgbClr val="172125"/>
                 </a:solidFill>
               </a:rPr>
-              <a:t>or ask Opus to invent a new one.</a:t>
+              <a:t>or ask the LLM to invent a new one.</a:t>
             </a:r>
           </a:p>
           <a:p/>
@@ -16404,7 +16404,7 @@
                   <a:srgbClr val="172125"/>
                 </a:solidFill>
               </a:rPr>
-              <a:t>Coach Lab streams a real Opus call from the browser using the user's own session key. The persona is authored during the demo, not pre-recorded.</a:t>
+              <a:t>Coach Lab streams a real LLM call from the browser using the user's own session key. The persona is authored during the demo, not pre-recorded.</a:t>
             </a:r>
           </a:p>
           <a:p/>
@@ -16415,7 +16415,7 @@
                   <a:srgbClr val="172125"/>
                 </a:solidFill>
               </a:rPr>
-              <a:t>Built end-to-end with Claude Code.</a:t>
+              <a:t>Built end-to-end with an agentic coding tool.</a:t>
             </a:r>
           </a:p>
           <a:p/>

</xml_diff>